<commit_message>
plans/ppt：部署章節改成 deploy_source.sh 流程（W2 s11–s17、W6 s2/s13）
- W2 三層架構圖重畫（Local → deploy_source.sh → VM ~/tw-selfselect → 容器 tw_selfselect_bot），
  說明 whl 進 git、p12／ini 不進、舊目錄保留可回滾
- W2 s14–s16 拿掉 pyarmor／加密版／deploy_crypted/deploy_user；改成 ./deploy_source.sh
  （preflight 測試 → build → SSH 直傳 → 載入 → 驗指紋）與四個掛載
- W2 s17 指令速查更新：./deploy_source.sh、docker compose down/up、docker logs tw_selfselect_bot
- W6 s2 講稿第五步、W6 s13 內文/講稿改成 deploy_source.sh；s13 舊 deploy_user.sh 截圖移除留提示
- 修剪圖文後以 LibreOffice 抽頁確認版面
</commit_message>
<xml_diff>
--- a/plans/ppt/TW-SELFSELECT台股買賣自動化系統-W6-講稿版.pptx
+++ b/plans/ppt/TW-SELFSELECT台股買賣自動化系統-W6-講稿版.pptx
@@ -2966,18 +2966,13 @@
           </a:p>
           <a:p>
             <a:r>
-              <a:t>如果你是試用版，沒有 selfselect_trader.py 源碼，執行 deploy_crypted.sh；如果你有購買源碼，把 selfselect_trader.py 源碼複製到 WSL 的 tw-selfselect 目錄下，執行 deploy_user.sh。</a:t>
-            </a:r>
-          </a:p>
-          <a:p>
-            <a:r>
-              <a:t>---</a:t>
+              <a:t>在專案根目錄執行 ./deploy_source.sh：它會先跑 preflight 測試（紅燈就中止），接著在本機建 Docker image、透過 SSH 直傳到 VM 載入、重啟容器，最後比對 core/version.py 的版本指紋，不符就中止並印出容器日誌。舊版的 deploy_crypted.sh／deploy_user.sh 已經不需要了。</a:t>
             </a:r>
           </a:p>
           <a:p/>
           <a:p>
             <a:r>
-              <a:t>【講師提示】確認學員知道自己屬於哪一種，對應哪個指令。</a:t>
+              <a:t>【講師提示】強調「部署前測試、部署後驗指紋」兩道關卡，這是避免上錯版本的關鍵。</a:t>
             </a:r>
           </a:p>
         </p:txBody>
@@ -3874,17 +3869,12 @@
           </a:p>
           <a:p>
             <a:r>
-              <a:t>第四步，設定雲端主機：確認靜態 IP；如果主機停機中，要先開啟；執行驗證之後，才能上傳到 VM。</a:t>
-            </a:r>
-          </a:p>
-          <a:p>
-            <a:r>
-              <a:t>第五步，Deploy：執行 deploy_crypted.sh 上傳加密主程式，或 deploy_user.sh 上傳沒加密的主程式。注意：如果 VM 非開機時間，上傳完要手動關機——否則下一個開機時間不會自行開機，因為開機時間到了程式仍處於休眠狀態。</a:t>
-            </a:r>
-          </a:p>
-          <a:p>
-            <a:r>
-              <a:t>---</a:t>
+              <a:t>第四步，設定雲端主機：確認靜態 IP；如果主機停機中，要先開啟；執行驗證之後，才能部署到 VM。</a:t>
+            </a:r>
+          </a:p>
+          <a:p>
+            <a:r>
+              <a:t>第五步，部署：在專案根目錄執行 ./deploy_source.sh（人工執行）——它會先跑 preflight 測試、建 image、透過 SSH 直傳到 VM、載入後重啟容器，最後比對版本指紋。注意：如果 VM 非開機時間，部署完要手動關機，否則下一個開機時間不會自行開機。</a:t>
             </a:r>
           </a:p>
           <a:p/>
@@ -13703,137 +13693,32 @@
           <a:lstStyle/>
           <a:p>
             <a:r>
-              <a:rPr lang="zh-TW" altLang="en-US" dirty="0"/>
-              <a:t>如果你是試用</a:t>
-            </a:r>
-            <a:r>
-              <a:rPr lang="en-US" altLang="zh-TW" dirty="0"/>
-              <a:t>,</a:t>
-            </a:r>
-            <a:r>
-              <a:rPr lang="zh-TW" altLang="en-US" dirty="0"/>
-              <a:t>沒有</a:t>
-            </a:r>
-            <a:r>
-              <a:rPr lang="en-US" altLang="zh-TW" dirty="0"/>
-              <a:t>selfselect_trader.py</a:t>
-            </a:r>
-            <a:r>
-              <a:rPr lang="zh-TW" altLang="en-US" dirty="0"/>
-              <a:t>源碼</a:t>
-            </a:r>
-            <a:r>
-              <a:rPr lang="en-US" altLang="zh-TW" dirty="0"/>
-              <a:t>=&gt;./deploy_crypted.sh</a:t>
-            </a:r>
-            <a:br>
-              <a:rPr lang="en-US" altLang="zh-TW" dirty="0"/>
-            </a:br>
-            <a:r>
-              <a:rPr lang="zh-TW" altLang="en-US" dirty="0"/>
-              <a:t>如果你有購買</a:t>
-            </a:r>
-            <a:r>
-              <a:rPr lang="en-US" altLang="zh-TW" dirty="0"/>
-              <a:t>selfselect_trader.py</a:t>
-            </a:r>
-            <a:r>
-              <a:rPr lang="zh-TW" altLang="en-US" dirty="0"/>
-              <a:t>源碼</a:t>
-            </a:r>
-            <a:r>
-              <a:rPr lang="en-US" altLang="zh-TW" dirty="0"/>
-              <a:t>,</a:t>
-            </a:r>
-            <a:r>
-              <a:rPr lang="zh-TW" altLang="en-US" dirty="0"/>
-              <a:t>把</a:t>
-            </a:r>
-            <a:r>
-              <a:rPr lang="en-US" altLang="zh-TW" dirty="0"/>
-              <a:t>selfselect_trader.py</a:t>
-            </a:r>
-            <a:r>
-              <a:rPr lang="zh-TW" altLang="en-US" dirty="0"/>
-              <a:t>源碼複製到</a:t>
-            </a:r>
-            <a:r>
-              <a:rPr lang="en-US" altLang="zh-TW" dirty="0" err="1"/>
-              <a:t>wsl</a:t>
-            </a:r>
-            <a:r>
-              <a:rPr lang="en-US" altLang="zh-TW" dirty="0"/>
-              <a:t> </a:t>
-            </a:r>
-            <a:r>
-              <a:rPr lang="en-US" altLang="zh-TW" dirty="0" err="1"/>
-              <a:t>linux</a:t>
-            </a:r>
-            <a:r>
-              <a:rPr lang="zh-TW" altLang="en-US" dirty="0"/>
-              <a:t>的</a:t>
-            </a:r>
-            <a:br>
-              <a:rPr lang="en-US" altLang="zh-TW" dirty="0"/>
-            </a:br>
-            <a:r>
-              <a:rPr lang="en-US" altLang="zh-TW" dirty="0"/>
-              <a:t>~/</a:t>
-            </a:r>
-            <a:r>
-              <a:rPr lang="en-US" altLang="zh-TW" dirty="0" err="1"/>
-              <a:t>tw</a:t>
-            </a:r>
-            <a:r>
-              <a:rPr lang="en-US" altLang="zh-TW" dirty="0"/>
-              <a:t>-Autotrader/</a:t>
-            </a:r>
-            <a:r>
-              <a:rPr lang="zh-TW" altLang="en-US" dirty="0"/>
-              <a:t>下於</a:t>
-            </a:r>
-            <a:r>
-              <a:rPr lang="en-US" altLang="zh-TW" dirty="0" err="1"/>
-              <a:t>wsl</a:t>
-            </a:r>
-            <a:r>
-              <a:rPr lang="zh-TW" altLang="en-US" dirty="0"/>
-              <a:t>中執行</a:t>
-            </a:r>
-            <a:r>
-              <a:rPr lang="en-US" altLang="zh-TW" dirty="0"/>
-              <a:t>=&gt;./deploy_user.sh</a:t>
-            </a:r>
-            <a:br>
-              <a:rPr lang="en-US" altLang="zh-TW" dirty="0"/>
-            </a:br>
-            <a:endParaRPr lang="en-US" altLang="zh-TW" dirty="0"/>
-          </a:p>
-          <a:p>
-            <a:endParaRPr lang="zh-TW" altLang="en-US" dirty="0"/>
+              <a:t>在 WSL 的 ~/tw-selfselect/ 目錄執行：</a:t>
+            </a:r>
+          </a:p>
+          <a:p>
+            <a:r>
+              <a:t>./deploy_source.sh</a:t>
+            </a:r>
+          </a:p>
+          <a:p>
+            <a:r>
+              <a:t>（preflight 測試 → 建 image → SSH 直傳 → VM 載入 → 重啟容器 → 驗證指紋）</a:t>
+            </a:r>
+          </a:p>
+          <a:p>
+            <a:r>
+              <a:t>不再有加密版／源碼版兩種腳本——本專案一律源碼部署。</a:t>
+            </a:r>
           </a:p>
         </p:txBody>
       </p:sp>
-      <p:pic>
-        <p:nvPicPr>
-          <p:cNvPr id="7" name="圖片 6">
-            <a:extLst>
-              <a:ext uri="{FF2B5EF4-FFF2-40B4-BE49-F238E27FC236}">
-                <a16:creationId xmlns:a16="http://schemas.microsoft.com/office/drawing/2014/main" id="{FF81FE1C-22E2-E821-E15D-0C4922502D11}"/>
-              </a:ext>
-            </a:extLst>
-          </p:cNvPr>
-          <p:cNvPicPr>
-            <a:picLocks noChangeAspect="1"/>
-          </p:cNvPicPr>
+      <p:sp>
+        <p:nvSpPr>
+          <p:cNvPr id="5" name="TextBox 4"/>
+          <p:cNvSpPr txBox="1"/>
           <p:nvPr/>
-        </p:nvPicPr>
-        <p:blipFill>
-          <a:blip r:embed="rId2"/>
-          <a:stretch>
-            <a:fillRect/>
-          </a:stretch>
-        </p:blipFill>
+        </p:nvSpPr>
         <p:spPr>
           <a:xfrm>
             <a:off x="1446212" y="2286000"/>
@@ -13842,8 +13727,26 @@
           <a:prstGeom prst="rect">
             <a:avLst/>
           </a:prstGeom>
+          <a:noFill/>
         </p:spPr>
-      </p:pic>
+        <p:txBody>
+          <a:bodyPr wrap="square" anchor="ctr">
+            <a:spAutoFit/>
+          </a:bodyPr>
+          <a:lstStyle/>
+          <a:p>
+            <a:pPr algn="ctr"/>
+            <a:r>
+              <a:rPr sz="1400" i="1">
+                <a:solidFill>
+                  <a:srgbClr val="999999"/>
+                </a:solidFill>
+              </a:rPr>
+              <a:t>（./deploy_source.sh 實際輸出截圖待補）</a:t>
+            </a:r>
+          </a:p>
+        </p:txBody>
+      </p:sp>
     </p:spTree>
     <p:extLst>
       <p:ext uri="{BB962C8B-B14F-4D97-AF65-F5344CB8AC3E}">

</xml_diff>